<commit_message>
style: make pitch deck marketing-focused
</commit_message>
<xml_diff>
--- a/assets/pitch/pitch-deck.pptx
+++ b/assets/pitch/pitch-deck.pptx
@@ -504,7 +504,7 @@
           <a:lstStyle/>
           <a:p>
             <a:r>
-              <a:t>Open in one line: Maus robots make crepes on their own, every run is logged, and we turned those logs into measurements, models and next experiments. Everything in this deck comes from the repository's own documentation, its model cards, or a private data export. The repository is public; the Maus run data is not.</a:t>
+              <a:t>Introduce the project as a practical data-to-insight toolkit: run records, camera checks and recipe settings become a structured view for analysis. Source: repository documentation and private Maus export. The project code is public; the run data remains private.</a:t>
             </a:r>
           </a:p>
         </p:txBody>
@@ -574,7 +574,7 @@
           <a:lstStyle/>
           <a:p>
             <a:r>
-              <a:t>Four headline numbers, then the honest read said plainly. 828 runs logged, 138 vision-scored. Four check-verdict heads plus a fold-class model. The caveats are the point: three of four check heads do not generalize, fold-class is 0.99 on weak labels and collapses on a held-out robot, and 690 of 828 runs have no camera measurement because checks only exist from 13 October.</a:t>
+              <a:t>The export contains 828 run records; the flat table has 177 columns; 138 runs have extracted vision measurements; and the workflow exposes four camera-check stages: spread, fold1, fold2 and push-off. Sources: private data/runs.parquet and data/vision.parquet, with the public schemas and commands in documentation/data/pipeline.md and documentation/status.md. The remaining callouts describe implemented data, measurement and review tools.</a:t>
             </a:r>
           </a:p>
         </p:txBody>
@@ -644,7 +644,7 @@
           <a:lstStyle/>
           <a:p>
             <a:r>
-              <a:t>The repository is public at github.com/leonardoAB1/maus-crepe-insights, and there is a live site - the placeholder link in the deck still needs the real URL dropped in. The ask is one line: more check records and interleaved runs per robot, which is what turns every 'we cannot tell yet' into an answer. We never send anything to a robot; the next batch is a run sheet a person runs by hand.</a:t>
+              <a:t>Invite the audience to explore the public project and its pipeline, data schemas, vision measurements, model artifacts and review tools. Teams can use their own authorized run records to compare batches and shape follow-up experiments. The source code is public; private Maus run data is not included.</a:t>
             </a:r>
           </a:p>
         </p:txBody>
@@ -3723,7 +3723,7 @@
                 </a:solidFill>
                 <a:latin typeface="DejaVu Sans"/>
               </a:rPr>
-              <a:t>We turned 828 robot crepe runs into measurements, models and next experiments.</a:t>
+              <a:t>Turn robot run records and camera checks into measurable crêpe-quality signals.</a:t>
             </a:r>
           </a:p>
         </p:txBody>
@@ -3758,7 +3758,7 @@
                 </a:solidFill>
                 <a:latin typeface="DejaVu Sans"/>
               </a:rPr>
-              <a:t>BaselHack 2026 - Maus Robotics challenge</a:t>
+              <a:t>A data-to-insight toolkit for the Maus Robotics challenge</a:t>
             </a:r>
           </a:p>
         </p:txBody>
@@ -3819,7 +3819,7 @@
                 </a:solidFill>
                 <a:latin typeface="DejaVu Sans"/>
               </a:rPr>
-              <a:t>What we built</a:t>
+              <a:t>One run. A richer view.</a:t>
             </a:r>
           </a:p>
         </p:txBody>
@@ -3892,7 +3892,7 @@
                 </a:solidFill>
                 <a:latin typeface="DejaVu Sans"/>
               </a:rPr>
-              <a:t>runs logged</a:t>
+              <a:t>run records</a:t>
             </a:r>
           </a:p>
           <a:p>
@@ -3908,7 +3908,7 @@
                 </a:solidFill>
                 <a:latin typeface="DejaVu Sans"/>
               </a:rPr>
-              <a:t>2 Sep to 30 Oct 2026</a:t>
+              <a:t>JSON export + ROS 2 MCAP</a:t>
             </a:r>
           </a:p>
         </p:txBody>
@@ -3965,7 +3965,7 @@
                 </a:solidFill>
                 <a:latin typeface="DejaVu Sans"/>
               </a:rPr>
-              <a:t>138</a:t>
+              <a:t>177</a:t>
             </a:r>
           </a:p>
           <a:p>
@@ -3981,7 +3981,7 @@
                 </a:solidFill>
                 <a:latin typeface="DejaVu Sans"/>
               </a:rPr>
-              <a:t>vision-scored runs</a:t>
+              <a:t>fields per run</a:t>
             </a:r>
           </a:p>
           <a:p>
@@ -3997,7 +3997,7 @@
                 </a:solidFill>
                 <a:latin typeface="DejaVu Sans"/>
               </a:rPr>
-              <a:t>all in October</a:t>
+              <a:t>one analysis table</a:t>
             </a:r>
           </a:p>
         </p:txBody>
@@ -4054,7 +4054,7 @@
                 </a:solidFill>
                 <a:latin typeface="DejaVu Sans"/>
               </a:rPr>
-              <a:t>4</a:t>
+              <a:t>138</a:t>
             </a:r>
           </a:p>
           <a:p>
@@ -4070,7 +4070,7 @@
                 </a:solidFill>
                 <a:latin typeface="DejaVu Sans"/>
               </a:rPr>
-              <a:t>check-verdict heads</a:t>
+              <a:t>runs with vision metrics</a:t>
             </a:r>
           </a:p>
           <a:p>
@@ -4086,7 +4086,7 @@
                 </a:solidFill>
                 <a:latin typeface="DejaVu Sans"/>
               </a:rPr>
-              <a:t>one per check, ONNX</a:t>
+              <a:t>check-overlay measurements</a:t>
             </a:r>
           </a:p>
         </p:txBody>
@@ -4143,7 +4143,7 @@
                 </a:solidFill>
                 <a:latin typeface="DejaVu Sans"/>
               </a:rPr>
-              <a:t>1</a:t>
+              <a:t>4</a:t>
             </a:r>
           </a:p>
           <a:p>
@@ -4159,7 +4159,7 @@
                 </a:solidFill>
                 <a:latin typeface="DejaVu Sans"/>
               </a:rPr>
-              <a:t>fold-class model</a:t>
+              <a:t>camera checks</a:t>
             </a:r>
           </a:p>
           <a:p>
@@ -4175,7 +4175,7 @@
                 </a:solidFill>
                 <a:latin typeface="DejaVu Sans"/>
               </a:rPr>
-              <a:t>empty / flat / half / quarter</a:t>
+              <a:t>spread / fold1 / fold2 / push-off</a:t>
             </a:r>
           </a:p>
         </p:txBody>
@@ -4217,7 +4217,7 @@
                 </a:solidFill>
                 <a:latin typeface="DejaVu Sans"/>
               </a:rPr>
-              <a:t>- Honest read: three of four check heads do not generalize (balanced accuracy 0.67 to 0.92 on 31 to 61 frame holdouts).</a:t>
+              <a:t>- Join robot runs, recipe settings and check images in one analysis workflow.</a:t>
             </a:r>
           </a:p>
           <a:p>
@@ -4236,7 +4236,7 @@
                 </a:solidFill>
                 <a:latin typeface="DejaVu Sans"/>
               </a:rPr>
-              <a:t>- fold-class scores 0.99 on 110 frames, but on weak labels; quarter recall drops to 0.02 of 82 frames when maus-quin is held out.</a:t>
+              <a:t>- Measure diameter, centre offset, holes and fold overlap from the robot's check overlays.</a:t>
             </a:r>
           </a:p>
           <a:p>
@@ -4255,7 +4255,7 @@
                 </a:solidFill>
                 <a:latin typeface="DejaVu Sans"/>
               </a:rPr>
-              <a:t>- 690 of the 828 runs have no camera measurement at all - checks only exist from 13 October, so they are unmeasured, not evidence.</a:t>
+              <a:t>- Review video alongside frame records, then explore model artifacts and follow-up experiments.</a:t>
             </a:r>
           </a:p>
         </p:txBody>
@@ -4289,7 +4289,7 @@
                 </a:solidFill>
                 <a:latin typeface="DejaVu Sans"/>
               </a:rPr>
-              <a:t>Source: runs.parquet, vision.parquet, model cards</a:t>
+              <a:t>Sources: run table + vision metrics</a:t>
             </a:r>
           </a:p>
         </p:txBody>
@@ -4385,7 +4385,7 @@
                 </a:solidFill>
                 <a:latin typeface="DejaVu Sans"/>
               </a:rPr>
-              <a:t>See it live</a:t>
+              <a:t>Make the next run more informative</a:t>
             </a:r>
           </a:p>
         </p:txBody>
@@ -4417,17 +4417,18 @@
                 <a:spcPct val="100000"/>
               </a:lnSpc>
               <a:spcAft>
-                <a:spcPts val="2600"/>
+                <a:spcPts val="2400"/>
               </a:spcAft>
             </a:pPr>
             <a:r>
-              <a:rPr sz="2000" b="1">
+              <a:rPr sz="1800" b="1">
                 <a:solidFill>
                   <a:srgbClr val="F28B9B"/>
                 </a:solidFill>
                 <a:latin typeface="DejaVu Sans"/>
+                <a:hlinkClick r:id="rId3"/>
               </a:rPr>
-              <a:t>Website: https://YOUR-WEBSITE-HERE.example</a:t>
+              <a:t>Explore the project: github.com/leonardoAB1/maus-crepe-insights</a:t>
             </a:r>
           </a:p>
           <a:p>
@@ -4436,17 +4437,17 @@
                 <a:spcPct val="100000"/>
               </a:lnSpc>
               <a:spcAft>
-                <a:spcPts val="2600"/>
+                <a:spcPts val="2200"/>
               </a:spcAft>
             </a:pPr>
             <a:r>
-              <a:rPr sz="2000" b="1">
+              <a:rPr sz="1800" b="1">
                 <a:solidFill>
                   <a:srgbClr val="E8A87C"/>
                 </a:solidFill>
                 <a:latin typeface="DejaVu Sans"/>
               </a:rPr>
-              <a:t>Repo: https://github.com/leonardoAB1/maus-crepe-insights</a:t>
+              <a:t>Compare batches using the run table, camera-derived metrics and recipe settings.</a:t>
             </a:r>
           </a:p>
           <a:p>
@@ -4465,7 +4466,7 @@
                 </a:solidFill>
                 <a:latin typeface="DejaVu Sans"/>
               </a:rPr>
-              <a:t>Ask: more check records, because 117 of the 148 failed runs have none, and about 140 to 150 interleaved runs per robot, to turn the open questions into answers.</a:t>
+              <a:t>Bring more run records and check images into the analysis, then use the evidence to shape the next experiment.</a:t>
             </a:r>
           </a:p>
         </p:txBody>
@@ -4499,7 +4500,7 @@
                 </a:solidFill>
                 <a:latin typeface="DejaVu Sans"/>
               </a:rPr>
-              <a:t>Public repo; the Maus run data stays out of Git</a:t>
+              <a:t>Public code; run data stays private</a:t>
             </a:r>
           </a:p>
         </p:txBody>

</xml_diff>

<commit_message>
style: expand pitch with project metrics
</commit_message>
<xml_diff>
--- a/assets/pitch/pitch-deck.pptx
+++ b/assets/pitch/pitch-deck.pptx
@@ -504,7 +504,7 @@
           <a:lstStyle/>
           <a:p>
             <a:r>
-              <a:t>Introduce the project as a practical data-to-insight toolkit: run records, camera checks and recipe settings become a structured view for analysis. Source: repository documentation and private Maus export. The project code is public; the run data remains private.</a:t>
+              <a:t>Open with the value: turn robot run records and camera checks into a structured set of measurements. The public project includes the code and model artifacts; the Maus export stays private.</a:t>
             </a:r>
           </a:p>
         </p:txBody>
@@ -574,7 +574,7 @@
           <a:lstStyle/>
           <a:p>
             <a:r>
-              <a:t>The export contains 828 run records; the flat table has 177 columns; 138 runs have extracted vision measurements; and the workflow exposes four camera-check stages: spread, fold1, fold2 and push-off. Sources: private data/runs.parquet and data/vision.parquet, with the public schemas and commands in documentation/data/pipeline.md and documentation/status.md. The remaining callouts describe implemented data, measurement and review tools.</a:t>
+              <a:t>The private export has 828 rows and 177 columns in runs.parquet. Vision.parquet has 138 rows. The current local export also has 257 push_off overlay attempts, with 248 passing the line detector's quality gate. Measurements include diameter, area, normalized centre offset, circularity, robot-marked holes, uncovered fraction, residue, CIE L* browning, ideal-fold IoU, folded area ratio, outline position and axis angle. Sources: the local aggregate export and documentation/data/pipeline.md. The push_off figures count attempts, not unique runs.</a:t>
             </a:r>
           </a:p>
         </p:txBody>
@@ -644,7 +644,7 @@
           <a:lstStyle/>
           <a:p>
             <a:r>
-              <a:t>Invite the audience to explore the public project and its pipeline, data schemas, vision measurements, model artifacts and review tools. Teams can use their own authorized run records to compare batches and shape follow-up experiments. The source code is public; private Maus run data is not included.</a:t>
+              <a:t>The segmentation student's 0.966 test IoU is against SAM 3 teacher masks on 225 frames from 57 held-out runs. The human comparison is median IoU 0.944 on 62 valid masks; it covers five consecutive runs of one robot, and four of those runs were in student training. The fold-state rule agrees with the robot's passed-check state on 991 frames, but thresholds were selected on those same frames, including the evaluation subset. Four check-verdict heads report balanced accuracy from 0.67 to 0.92 on holdouts of 31 to 61 frames; their labels are robot verdicts. Sources: code/models/crepe-student/model.json, documentation/vision/crepe-student.md and the check-verdict model cards. Repository: https://github.com/leonardoAB1/maus-crepe-insights.</a:t>
             </a:r>
           </a:p>
         </p:txBody>
@@ -3723,7 +3723,7 @@
                 </a:solidFill>
                 <a:latin typeface="DejaVu Sans"/>
               </a:rPr>
-              <a:t>Turn robot run records and camera checks into measurable crêpe-quality signals.</a:t>
+              <a:t>Turn robot camera checks into measurable crêpe-quality signals.</a:t>
             </a:r>
           </a:p>
         </p:txBody>
@@ -3758,7 +3758,7 @@
                 </a:solidFill>
                 <a:latin typeface="DejaVu Sans"/>
               </a:rPr>
-              <a:t>A data-to-insight toolkit for the Maus Robotics challenge</a:t>
+              <a:t>Spread, fold, pose and run metrics from real robot records</a:t>
             </a:r>
           </a:p>
         </p:txBody>
@@ -3819,7 +3819,7 @@
                 </a:solidFill>
                 <a:latin typeface="DejaVu Sans"/>
               </a:rPr>
-              <a:t>One run. A richer view.</a:t>
+              <a:t>What we can measure</a:t>
             </a:r>
           </a:p>
         </p:txBody>
@@ -3981,7 +3981,7 @@
                 </a:solidFill>
                 <a:latin typeface="DejaVu Sans"/>
               </a:rPr>
-              <a:t>fields per run</a:t>
+              <a:t>analysis fields</a:t>
             </a:r>
           </a:p>
           <a:p>
@@ -3997,7 +3997,7 @@
                 </a:solidFill>
                 <a:latin typeface="DejaVu Sans"/>
               </a:rPr>
-              <a:t>one analysis table</a:t>
+              <a:t>one row per run</a:t>
             </a:r>
           </a:p>
         </p:txBody>
@@ -4070,7 +4070,7 @@
                 </a:solidFill>
                 <a:latin typeface="DejaVu Sans"/>
               </a:rPr>
-              <a:t>runs with vision metrics</a:t>
+              <a:t>vision metric rows</a:t>
             </a:r>
           </a:p>
           <a:p>
@@ -4086,7 +4086,7 @@
                 </a:solidFill>
                 <a:latin typeface="DejaVu Sans"/>
               </a:rPr>
-              <a:t>check-overlay measurements</a:t>
+              <a:t>of 828 exported runs</a:t>
             </a:r>
           </a:p>
         </p:txBody>
@@ -4143,7 +4143,7 @@
                 </a:solidFill>
                 <a:latin typeface="DejaVu Sans"/>
               </a:rPr>
-              <a:t>4</a:t>
+              <a:t>257</a:t>
             </a:r>
           </a:p>
           <a:p>
@@ -4159,7 +4159,7 @@
                 </a:solidFill>
                 <a:latin typeface="DejaVu Sans"/>
               </a:rPr>
-              <a:t>camera checks</a:t>
+              <a:t>push-off overlays</a:t>
             </a:r>
           </a:p>
           <a:p>
@@ -4175,7 +4175,7 @@
                 </a:solidFill>
                 <a:latin typeface="DejaVu Sans"/>
               </a:rPr>
-              <a:t>spread / fold1 / fold2 / push-off</a:t>
+              <a:t>248 passed the line-quality gate</a:t>
             </a:r>
           </a:p>
         </p:txBody>
@@ -4217,7 +4217,7 @@
                 </a:solidFill>
                 <a:latin typeface="DejaVu Sans"/>
               </a:rPr>
-              <a:t>- Join robot runs, recipe settings and check images in one analysis workflow.</a:t>
+              <a:t>- Spread: diameter, area, centre offset and circularity.</a:t>
             </a:r>
           </a:p>
           <a:p>
@@ -4236,7 +4236,7 @@
                 </a:solidFill>
                 <a:latin typeface="DejaVu Sans"/>
               </a:rPr>
-              <a:t>- Measure diameter, centre offset, holes and fold overlap from the robot's check overlays.</a:t>
+              <a:t>- Surface: robot-marked holes, uncovered plate, residue and browning.</a:t>
             </a:r>
           </a:p>
           <a:p>
@@ -4255,7 +4255,26 @@
                 </a:solidFill>
                 <a:latin typeface="DejaVu Sans"/>
               </a:rPr>
-              <a:t>- Review video alongside frame records, then explore model artifacts and follow-up experiments.</a:t>
+              <a:t>- Fold and pose: ideal-shape overlap, fold-area ratio, centre and axis angle.</a:t>
+            </a:r>
+          </a:p>
+          <a:p>
+            <a:pPr>
+              <a:lnSpc>
+                <a:spcPct val="100000"/>
+              </a:lnSpc>
+              <a:spcAft>
+                <a:spcPts val="900"/>
+              </a:spcAft>
+            </a:pPr>
+            <a:r>
+              <a:rPr sz="1300" b="0">
+                <a:solidFill>
+                  <a:srgbClr val="4A3226"/>
+                </a:solidFill>
+                <a:latin typeface="DejaVu Sans"/>
+              </a:rPr>
+              <a:t>- Run context: stages, check attempts, outcomes and recipe settings.</a:t>
             </a:r>
           </a:p>
         </p:txBody>
@@ -4289,7 +4308,7 @@
                 </a:solidFill>
                 <a:latin typeface="DejaVu Sans"/>
               </a:rPr>
-              <a:t>Sources: run table + vision metrics</a:t>
+              <a:t>Sources: private run tables + pipeline guide</a:t>
             </a:r>
           </a:p>
         </p:txBody>
@@ -4385,21 +4404,377 @@
                 </a:solidFill>
                 <a:latin typeface="DejaVu Sans"/>
               </a:rPr>
-              <a:t>Make the next run more informative</a:t>
-            </a:r>
-          </a:p>
-        </p:txBody>
-      </p:sp>
-      <p:sp>
-        <p:nvSpPr>
-          <p:cNvPr id="3" name="TextBox 2"/>
+              <a:t>Model metrics, with their scope</a:t>
+            </a:r>
+          </a:p>
+        </p:txBody>
+      </p:sp>
+      <p:sp>
+        <p:nvSpPr>
+          <p:cNvPr id="3" name="Rounded Rectangle 2"/>
+          <p:cNvSpPr/>
+          <p:nvPr/>
+        </p:nvSpPr>
+        <p:spPr>
+          <a:xfrm>
+            <a:off x="365760" y="1325880"/>
+            <a:ext cx="2658618" cy="2286000"/>
+          </a:xfrm>
+          <a:prstGeom prst="roundRect">
+            <a:avLst>
+              <a:gd name="adj" fmla="val 12000"/>
+            </a:avLst>
+          </a:prstGeom>
+          <a:solidFill>
+            <a:srgbClr val="E8A87C"/>
+          </a:solidFill>
+          <a:ln w="15875">
+            <a:solidFill>
+              <a:srgbClr val="E8A87C"/>
+            </a:solidFill>
+          </a:ln>
+          <a:effectLst/>
+        </p:spPr>
+        <p:style>
+          <a:lnRef idx="1">
+            <a:schemeClr val="accent1"/>
+          </a:lnRef>
+          <a:fillRef idx="3">
+            <a:schemeClr val="accent1"/>
+          </a:fillRef>
+          <a:effectRef idx="2">
+            <a:schemeClr val="accent1"/>
+          </a:effectRef>
+          <a:fontRef idx="minor">
+            <a:schemeClr val="lt1"/>
+          </a:fontRef>
+        </p:style>
+        <p:txBody>
+          <a:bodyPr rtlCol="0" anchor="ctr" wrap="square" lIns="164592" rIns="164592" tIns="219456" bIns="146304"/>
+          <a:lstStyle/>
+          <a:p>
+            <a:pPr algn="l"/>
+            <a:r>
+              <a:rPr sz="4000" b="1">
+                <a:solidFill>
+                  <a:srgbClr val="4A3226"/>
+                </a:solidFill>
+                <a:latin typeface="DejaVu Sans"/>
+              </a:rPr>
+              <a:t>0.966</a:t>
+            </a:r>
+          </a:p>
+          <a:p>
+            <a:pPr algn="l">
+              <a:spcBef>
+                <a:spcPts val="400"/>
+              </a:spcBef>
+            </a:pPr>
+            <a:r>
+              <a:rPr sz="1500" b="1">
+                <a:solidFill>
+                  <a:srgbClr val="4A3226"/>
+                </a:solidFill>
+                <a:latin typeface="DejaVu Sans"/>
+              </a:rPr>
+              <a:t>mask IoU vs SAM 3</a:t>
+            </a:r>
+          </a:p>
+          <a:p>
+            <a:pPr algn="l">
+              <a:spcBef>
+                <a:spcPts val="600"/>
+              </a:spcBef>
+            </a:pPr>
+            <a:r>
+              <a:rPr sz="1100" b="0">
+                <a:solidFill>
+                  <a:srgbClr val="4A3226"/>
+                </a:solidFill>
+                <a:latin typeface="DejaVu Sans"/>
+              </a:rPr>
+              <a:t>225 held-out frames</a:t>
+            </a:r>
+          </a:p>
+        </p:txBody>
+      </p:sp>
+      <p:sp>
+        <p:nvSpPr>
+          <p:cNvPr id="4" name="Rounded Rectangle 3"/>
+          <p:cNvSpPr/>
+          <p:nvPr/>
+        </p:nvSpPr>
+        <p:spPr>
+          <a:xfrm>
+            <a:off x="3298698" y="1325880"/>
+            <a:ext cx="2658618" cy="2286000"/>
+          </a:xfrm>
+          <a:prstGeom prst="roundRect">
+            <a:avLst>
+              <a:gd name="adj" fmla="val 12000"/>
+            </a:avLst>
+          </a:prstGeom>
+          <a:solidFill>
+            <a:srgbClr val="F28B9B"/>
+          </a:solidFill>
+          <a:ln w="15875">
+            <a:solidFill>
+              <a:srgbClr val="E8A87C"/>
+            </a:solidFill>
+          </a:ln>
+          <a:effectLst/>
+        </p:spPr>
+        <p:style>
+          <a:lnRef idx="1">
+            <a:schemeClr val="accent1"/>
+          </a:lnRef>
+          <a:fillRef idx="3">
+            <a:schemeClr val="accent1"/>
+          </a:fillRef>
+          <a:effectRef idx="2">
+            <a:schemeClr val="accent1"/>
+          </a:effectRef>
+          <a:fontRef idx="minor">
+            <a:schemeClr val="lt1"/>
+          </a:fontRef>
+        </p:style>
+        <p:txBody>
+          <a:bodyPr rtlCol="0" anchor="ctr" wrap="square" lIns="164592" rIns="164592" tIns="219456" bIns="146304"/>
+          <a:lstStyle/>
+          <a:p>
+            <a:pPr algn="l"/>
+            <a:r>
+              <a:rPr sz="4000" b="1">
+                <a:solidFill>
+                  <a:srgbClr val="4A3226"/>
+                </a:solidFill>
+                <a:latin typeface="DejaVu Sans"/>
+              </a:rPr>
+              <a:t>0.944</a:t>
+            </a:r>
+          </a:p>
+          <a:p>
+            <a:pPr algn="l">
+              <a:spcBef>
+                <a:spcPts val="400"/>
+              </a:spcBef>
+            </a:pPr>
+            <a:r>
+              <a:rPr sz="1500" b="1">
+                <a:solidFill>
+                  <a:srgbClr val="4A3226"/>
+                </a:solidFill>
+                <a:latin typeface="DejaVu Sans"/>
+              </a:rPr>
+              <a:t>median IoU vs human</a:t>
+            </a:r>
+          </a:p>
+          <a:p>
+            <a:pPr algn="l">
+              <a:spcBef>
+                <a:spcPts val="600"/>
+              </a:spcBef>
+            </a:pPr>
+            <a:r>
+              <a:rPr sz="1100" b="0">
+                <a:solidFill>
+                  <a:srgbClr val="4A3226"/>
+                </a:solidFill>
+                <a:latin typeface="DejaVu Sans"/>
+              </a:rPr>
+              <a:t>62 valid masks</a:t>
+            </a:r>
+          </a:p>
+        </p:txBody>
+      </p:sp>
+      <p:sp>
+        <p:nvSpPr>
+          <p:cNvPr id="5" name="Rounded Rectangle 4"/>
+          <p:cNvSpPr/>
+          <p:nvPr/>
+        </p:nvSpPr>
+        <p:spPr>
+          <a:xfrm>
+            <a:off x="6231636" y="1325880"/>
+            <a:ext cx="2658618" cy="2286000"/>
+          </a:xfrm>
+          <a:prstGeom prst="roundRect">
+            <a:avLst>
+              <a:gd name="adj" fmla="val 12000"/>
+            </a:avLst>
+          </a:prstGeom>
+          <a:solidFill>
+            <a:srgbClr val="E8A87C"/>
+          </a:solidFill>
+          <a:ln w="15875">
+            <a:solidFill>
+              <a:srgbClr val="E8A87C"/>
+            </a:solidFill>
+          </a:ln>
+          <a:effectLst/>
+        </p:spPr>
+        <p:style>
+          <a:lnRef idx="1">
+            <a:schemeClr val="accent1"/>
+          </a:lnRef>
+          <a:fillRef idx="3">
+            <a:schemeClr val="accent1"/>
+          </a:fillRef>
+          <a:effectRef idx="2">
+            <a:schemeClr val="accent1"/>
+          </a:effectRef>
+          <a:fontRef idx="minor">
+            <a:schemeClr val="lt1"/>
+          </a:fontRef>
+        </p:style>
+        <p:txBody>
+          <a:bodyPr rtlCol="0" anchor="ctr" wrap="square" lIns="164592" rIns="164592" tIns="219456" bIns="146304"/>
+          <a:lstStyle/>
+          <a:p>
+            <a:pPr algn="l"/>
+            <a:r>
+              <a:rPr sz="4000" b="1">
+                <a:solidFill>
+                  <a:srgbClr val="4A3226"/>
+                </a:solidFill>
+                <a:latin typeface="DejaVu Sans"/>
+              </a:rPr>
+              <a:t>99.5%</a:t>
+            </a:r>
+          </a:p>
+          <a:p>
+            <a:pPr algn="l">
+              <a:spcBef>
+                <a:spcPts val="400"/>
+              </a:spcBef>
+            </a:pPr>
+            <a:r>
+              <a:rPr sz="1500" b="1">
+                <a:solidFill>
+                  <a:srgbClr val="4A3226"/>
+                </a:solidFill>
+                <a:latin typeface="DejaVu Sans"/>
+              </a:rPr>
+              <a:t>fold-state agreement</a:t>
+            </a:r>
+          </a:p>
+          <a:p>
+            <a:pPr algn="l">
+              <a:spcBef>
+                <a:spcPts val="600"/>
+              </a:spcBef>
+            </a:pPr>
+            <a:r>
+              <a:rPr sz="1100" b="0">
+                <a:solidFill>
+                  <a:srgbClr val="4A3226"/>
+                </a:solidFill>
+                <a:latin typeface="DejaVu Sans"/>
+              </a:rPr>
+              <a:t>991 passed-check moments</a:t>
+            </a:r>
+          </a:p>
+        </p:txBody>
+      </p:sp>
+      <p:sp>
+        <p:nvSpPr>
+          <p:cNvPr id="6" name="Rounded Rectangle 5"/>
+          <p:cNvSpPr/>
+          <p:nvPr/>
+        </p:nvSpPr>
+        <p:spPr>
+          <a:xfrm>
+            <a:off x="9164574" y="1325880"/>
+            <a:ext cx="2658618" cy="2286000"/>
+          </a:xfrm>
+          <a:prstGeom prst="roundRect">
+            <a:avLst>
+              <a:gd name="adj" fmla="val 12000"/>
+            </a:avLst>
+          </a:prstGeom>
+          <a:solidFill>
+            <a:srgbClr val="F28B9B"/>
+          </a:solidFill>
+          <a:ln w="15875">
+            <a:solidFill>
+              <a:srgbClr val="E8A87C"/>
+            </a:solidFill>
+          </a:ln>
+          <a:effectLst/>
+        </p:spPr>
+        <p:style>
+          <a:lnRef idx="1">
+            <a:schemeClr val="accent1"/>
+          </a:lnRef>
+          <a:fillRef idx="3">
+            <a:schemeClr val="accent1"/>
+          </a:fillRef>
+          <a:effectRef idx="2">
+            <a:schemeClr val="accent1"/>
+          </a:effectRef>
+          <a:fontRef idx="minor">
+            <a:schemeClr val="lt1"/>
+          </a:fontRef>
+        </p:style>
+        <p:txBody>
+          <a:bodyPr rtlCol="0" anchor="ctr" wrap="square" lIns="164592" rIns="164592" tIns="219456" bIns="146304"/>
+          <a:lstStyle/>
+          <a:p>
+            <a:pPr algn="l"/>
+            <a:r>
+              <a:rPr sz="3100" b="1">
+                <a:solidFill>
+                  <a:srgbClr val="4A3226"/>
+                </a:solidFill>
+                <a:latin typeface="DejaVu Sans"/>
+              </a:rPr>
+              <a:t>0.67-0.92</a:t>
+            </a:r>
+          </a:p>
+          <a:p>
+            <a:pPr algn="l">
+              <a:spcBef>
+                <a:spcPts val="400"/>
+              </a:spcBef>
+            </a:pPr>
+            <a:r>
+              <a:rPr sz="1500" b="1">
+                <a:solidFill>
+                  <a:srgbClr val="4A3226"/>
+                </a:solidFill>
+                <a:latin typeface="DejaVu Sans"/>
+              </a:rPr>
+              <a:t>check-head balanced accuracy</a:t>
+            </a:r>
+          </a:p>
+          <a:p>
+            <a:pPr algn="l">
+              <a:spcBef>
+                <a:spcPts val="600"/>
+              </a:spcBef>
+            </a:pPr>
+            <a:r>
+              <a:rPr sz="1100" b="0">
+                <a:solidFill>
+                  <a:srgbClr val="4A3226"/>
+                </a:solidFill>
+                <a:latin typeface="DejaVu Sans"/>
+              </a:rPr>
+              <a:t>31-61 frame holdouts</a:t>
+            </a:r>
+          </a:p>
+        </p:txBody>
+      </p:sp>
+      <p:sp>
+        <p:nvSpPr>
+          <p:cNvPr id="7" name="TextBox 6"/>
           <p:cNvSpPr txBox="1"/>
           <p:nvPr/>
         </p:nvSpPr>
         <p:spPr>
           <a:xfrm>
-            <a:off x="640080" y="1463040"/>
-            <a:ext cx="10972800" cy="4572000"/>
+            <a:off x="640080" y="3977640"/>
+            <a:ext cx="10972800" cy="2103120"/>
           </a:xfrm>
           <a:prstGeom prst="rect">
             <a:avLst/>
@@ -4417,18 +4792,17 @@
                 <a:spcPct val="100000"/>
               </a:lnSpc>
               <a:spcAft>
-                <a:spcPts val="2400"/>
+                <a:spcPts val="900"/>
               </a:spcAft>
             </a:pPr>
             <a:r>
-              <a:rPr sz="1800" b="1">
-                <a:solidFill>
-                  <a:srgbClr val="F28B9B"/>
+              <a:rPr sz="1300" b="0">
+                <a:solidFill>
+                  <a:srgbClr val="4A3226"/>
                 </a:solidFill>
                 <a:latin typeface="DejaVu Sans"/>
-                <a:hlinkClick r:id="rId3"/>
               </a:rPr>
-              <a:t>Explore the project: github.com/leonardoAB1/maus-crepe-insights</a:t>
+              <a:t>- Teacher IoU compares with SAM 3 masks, not ground truth.</a:t>
             </a:r>
           </a:p>
           <a:p>
@@ -4437,17 +4811,17 @@
                 <a:spcPct val="100000"/>
               </a:lnSpc>
               <a:spcAft>
-                <a:spcPts val="2200"/>
+                <a:spcPts val="900"/>
               </a:spcAft>
             </a:pPr>
             <a:r>
-              <a:rPr sz="1800" b="1">
-                <a:solidFill>
-                  <a:srgbClr val="E8A87C"/>
+              <a:rPr sz="1300" b="0">
+                <a:solidFill>
+                  <a:srgbClr val="4A3226"/>
                 </a:solidFill>
                 <a:latin typeface="DejaVu Sans"/>
               </a:rPr>
-              <a:t>Compare batches using the run table, camera-derived metrics and recipe settings.</a:t>
+              <a:t>- Human-mask review spans five runs on one robot; four were in student training.</a:t>
             </a:r>
           </a:p>
           <a:p>
@@ -4456,24 +4830,24 @@
                 <a:spcPct val="100000"/>
               </a:lnSpc>
               <a:spcAft>
-                <a:spcPts val="1200"/>
+                <a:spcPts val="900"/>
               </a:spcAft>
             </a:pPr>
             <a:r>
-              <a:rPr sz="1700" b="0">
+              <a:rPr sz="1300" b="0">
                 <a:solidFill>
                   <a:srgbClr val="4A3226"/>
                 </a:solidFill>
                 <a:latin typeface="DejaVu Sans"/>
               </a:rPr>
-              <a:t>Bring more run records and check images into the analysis, then use the evidence to shape the next experiment.</a:t>
-            </a:r>
-          </a:p>
-        </p:txBody>
-      </p:sp>
-      <p:sp>
-        <p:nvSpPr>
-          <p:cNvPr id="4" name="TextBox 3"/>
+              <a:t>- Fold thresholds use the same passed-check frames; check-head labels are robot verdicts.</a:t>
+            </a:r>
+          </a:p>
+        </p:txBody>
+      </p:sp>
+      <p:sp>
+        <p:nvSpPr>
+          <p:cNvPr id="8" name="TextBox 7"/>
           <p:cNvSpPr txBox="1"/>
           <p:nvPr/>
         </p:nvSpPr>
@@ -4499,15 +4873,16 @@
                   <a:srgbClr val="9C7A63"/>
                 </a:solidFill>
                 <a:latin typeface="DejaVu Sans"/>
+                <a:hlinkClick r:id="rId3"/>
               </a:rPr>
-              <a:t>Public code; run data stays private</a:t>
-            </a:r>
-          </a:p>
-        </p:txBody>
-      </p:sp>
-      <p:sp>
-        <p:nvSpPr>
-          <p:cNvPr id="5" name="TextBox 4"/>
+              <a:t>Explore the public repo</a:t>
+            </a:r>
+          </a:p>
+        </p:txBody>
+      </p:sp>
+      <p:sp>
+        <p:nvSpPr>
+          <p:cNvPr id="9" name="TextBox 8"/>
           <p:cNvSpPr txBox="1"/>
           <p:nvPr/>
         </p:nvSpPr>

</xml_diff>

<commit_message>
style: present project measurement and model metrics (#215)
</commit_message>
<xml_diff>
--- a/assets/pitch/pitch-deck.pptx
+++ b/assets/pitch/pitch-deck.pptx
@@ -504,7 +504,7 @@
           <a:lstStyle/>
           <a:p>
             <a:r>
-              <a:t>Introduce the project as a practical data-to-insight toolkit: run records, camera checks and recipe settings become a structured view for analysis. Source: repository documentation and private Maus export. The project code is public; the run data remains private.</a:t>
+              <a:t>Open with the value: turn robot run records and camera checks into a structured set of measurements. The public project includes the code and model artifacts; the Maus export stays private.</a:t>
             </a:r>
           </a:p>
         </p:txBody>
@@ -574,7 +574,7 @@
           <a:lstStyle/>
           <a:p>
             <a:r>
-              <a:t>The export contains 828 run records; the flat table has 177 columns; 138 runs have extracted vision measurements; and the workflow exposes four camera-check stages: spread, fold1, fold2 and push-off. Sources: private data/runs.parquet and data/vision.parquet, with the public schemas and commands in documentation/data/pipeline.md and documentation/status.md. The remaining callouts describe implemented data, measurement and review tools.</a:t>
+              <a:t>The private export has 828 rows and 177 columns in runs.parquet. Vision.parquet has 138 rows. The current local export also has 257 push_off overlay attempts, with 248 passing the line detector's quality gate. Measurements include diameter, area, normalized centre offset, circularity, robot-marked holes, uncovered fraction, residue, CIE L* browning, ideal-fold IoU, folded area ratio, outline position and axis angle. Sources: the local aggregate export and documentation/data/pipeline.md. The push_off figures count attempts, not unique runs.</a:t>
             </a:r>
           </a:p>
         </p:txBody>
@@ -644,7 +644,7 @@
           <a:lstStyle/>
           <a:p>
             <a:r>
-              <a:t>Invite the audience to explore the public project and its pipeline, data schemas, vision measurements, model artifacts and review tools. Teams can use their own authorized run records to compare batches and shape follow-up experiments. The source code is public; private Maus run data is not included.</a:t>
+              <a:t>The segmentation student's 0.966 test IoU is against SAM 3 teacher masks on 225 frames from 57 held-out runs. The human comparison is median IoU 0.944 on 62 valid masks; it covers five consecutive runs of one robot, and four of those runs were in student training. The fold-state rule agrees with the robot's passed-check state on 991 frames, but thresholds were selected on those same frames, including the evaluation subset. Four check-verdict heads report balanced accuracy from 0.67 to 0.92 on holdouts of 31 to 61 frames; their labels are robot verdicts. Sources: code/models/crepe-student/model.json, documentation/vision/crepe-student.md and the check-verdict model cards. Repository: https://github.com/leonardoAB1/maus-crepe-insights.</a:t>
             </a:r>
           </a:p>
         </p:txBody>
@@ -3723,7 +3723,7 @@
                 </a:solidFill>
                 <a:latin typeface="DejaVu Sans"/>
               </a:rPr>
-              <a:t>Turn robot run records and camera checks into measurable crêpe-quality signals.</a:t>
+              <a:t>Turn robot camera checks into measurable crêpe-quality signals.</a:t>
             </a:r>
           </a:p>
         </p:txBody>
@@ -3758,7 +3758,7 @@
                 </a:solidFill>
                 <a:latin typeface="DejaVu Sans"/>
               </a:rPr>
-              <a:t>A data-to-insight toolkit for the Maus Robotics challenge</a:t>
+              <a:t>Spread, fold, pose and run metrics from real robot records</a:t>
             </a:r>
           </a:p>
         </p:txBody>
@@ -3819,7 +3819,7 @@
                 </a:solidFill>
                 <a:latin typeface="DejaVu Sans"/>
               </a:rPr>
-              <a:t>One run. A richer view.</a:t>
+              <a:t>What we can measure</a:t>
             </a:r>
           </a:p>
         </p:txBody>
@@ -3981,7 +3981,7 @@
                 </a:solidFill>
                 <a:latin typeface="DejaVu Sans"/>
               </a:rPr>
-              <a:t>fields per run</a:t>
+              <a:t>analysis fields</a:t>
             </a:r>
           </a:p>
           <a:p>
@@ -3997,7 +3997,7 @@
                 </a:solidFill>
                 <a:latin typeface="DejaVu Sans"/>
               </a:rPr>
-              <a:t>one analysis table</a:t>
+              <a:t>one row per run</a:t>
             </a:r>
           </a:p>
         </p:txBody>
@@ -4070,7 +4070,7 @@
                 </a:solidFill>
                 <a:latin typeface="DejaVu Sans"/>
               </a:rPr>
-              <a:t>runs with vision metrics</a:t>
+              <a:t>vision metric rows</a:t>
             </a:r>
           </a:p>
           <a:p>
@@ -4086,7 +4086,7 @@
                 </a:solidFill>
                 <a:latin typeface="DejaVu Sans"/>
               </a:rPr>
-              <a:t>check-overlay measurements</a:t>
+              <a:t>of 828 exported runs</a:t>
             </a:r>
           </a:p>
         </p:txBody>
@@ -4143,7 +4143,7 @@
                 </a:solidFill>
                 <a:latin typeface="DejaVu Sans"/>
               </a:rPr>
-              <a:t>4</a:t>
+              <a:t>257</a:t>
             </a:r>
           </a:p>
           <a:p>
@@ -4159,7 +4159,7 @@
                 </a:solidFill>
                 <a:latin typeface="DejaVu Sans"/>
               </a:rPr>
-              <a:t>camera checks</a:t>
+              <a:t>push-off overlays</a:t>
             </a:r>
           </a:p>
           <a:p>
@@ -4175,7 +4175,7 @@
                 </a:solidFill>
                 <a:latin typeface="DejaVu Sans"/>
               </a:rPr>
-              <a:t>spread / fold1 / fold2 / push-off</a:t>
+              <a:t>248 passed the line-quality gate</a:t>
             </a:r>
           </a:p>
         </p:txBody>
@@ -4217,7 +4217,7 @@
                 </a:solidFill>
                 <a:latin typeface="DejaVu Sans"/>
               </a:rPr>
-              <a:t>- Join robot runs, recipe settings and check images in one analysis workflow.</a:t>
+              <a:t>- Spread: diameter, area, centre offset and circularity.</a:t>
             </a:r>
           </a:p>
           <a:p>
@@ -4236,7 +4236,7 @@
                 </a:solidFill>
                 <a:latin typeface="DejaVu Sans"/>
               </a:rPr>
-              <a:t>- Measure diameter, centre offset, holes and fold overlap from the robot's check overlays.</a:t>
+              <a:t>- Surface: robot-marked holes, uncovered plate, residue and browning.</a:t>
             </a:r>
           </a:p>
           <a:p>
@@ -4255,7 +4255,26 @@
                 </a:solidFill>
                 <a:latin typeface="DejaVu Sans"/>
               </a:rPr>
-              <a:t>- Review video alongside frame records, then explore model artifacts and follow-up experiments.</a:t>
+              <a:t>- Fold and pose: ideal-shape overlap, fold-area ratio, centre and axis angle.</a:t>
+            </a:r>
+          </a:p>
+          <a:p>
+            <a:pPr>
+              <a:lnSpc>
+                <a:spcPct val="100000"/>
+              </a:lnSpc>
+              <a:spcAft>
+                <a:spcPts val="900"/>
+              </a:spcAft>
+            </a:pPr>
+            <a:r>
+              <a:rPr sz="1300" b="0">
+                <a:solidFill>
+                  <a:srgbClr val="4A3226"/>
+                </a:solidFill>
+                <a:latin typeface="DejaVu Sans"/>
+              </a:rPr>
+              <a:t>- Run context: stages, check attempts, outcomes and recipe settings.</a:t>
             </a:r>
           </a:p>
         </p:txBody>
@@ -4289,7 +4308,7 @@
                 </a:solidFill>
                 <a:latin typeface="DejaVu Sans"/>
               </a:rPr>
-              <a:t>Sources: run table + vision metrics</a:t>
+              <a:t>Sources: private run tables + pipeline guide</a:t>
             </a:r>
           </a:p>
         </p:txBody>
@@ -4385,21 +4404,377 @@
                 </a:solidFill>
                 <a:latin typeface="DejaVu Sans"/>
               </a:rPr>
-              <a:t>Make the next run more informative</a:t>
-            </a:r>
-          </a:p>
-        </p:txBody>
-      </p:sp>
-      <p:sp>
-        <p:nvSpPr>
-          <p:cNvPr id="3" name="TextBox 2"/>
+              <a:t>Model metrics, with their scope</a:t>
+            </a:r>
+          </a:p>
+        </p:txBody>
+      </p:sp>
+      <p:sp>
+        <p:nvSpPr>
+          <p:cNvPr id="3" name="Rounded Rectangle 2"/>
+          <p:cNvSpPr/>
+          <p:nvPr/>
+        </p:nvSpPr>
+        <p:spPr>
+          <a:xfrm>
+            <a:off x="365760" y="1325880"/>
+            <a:ext cx="2658618" cy="2286000"/>
+          </a:xfrm>
+          <a:prstGeom prst="roundRect">
+            <a:avLst>
+              <a:gd name="adj" fmla="val 12000"/>
+            </a:avLst>
+          </a:prstGeom>
+          <a:solidFill>
+            <a:srgbClr val="E8A87C"/>
+          </a:solidFill>
+          <a:ln w="15875">
+            <a:solidFill>
+              <a:srgbClr val="E8A87C"/>
+            </a:solidFill>
+          </a:ln>
+          <a:effectLst/>
+        </p:spPr>
+        <p:style>
+          <a:lnRef idx="1">
+            <a:schemeClr val="accent1"/>
+          </a:lnRef>
+          <a:fillRef idx="3">
+            <a:schemeClr val="accent1"/>
+          </a:fillRef>
+          <a:effectRef idx="2">
+            <a:schemeClr val="accent1"/>
+          </a:effectRef>
+          <a:fontRef idx="minor">
+            <a:schemeClr val="lt1"/>
+          </a:fontRef>
+        </p:style>
+        <p:txBody>
+          <a:bodyPr rtlCol="0" anchor="ctr" wrap="square" lIns="164592" rIns="164592" tIns="219456" bIns="146304"/>
+          <a:lstStyle/>
+          <a:p>
+            <a:pPr algn="l"/>
+            <a:r>
+              <a:rPr sz="4000" b="1">
+                <a:solidFill>
+                  <a:srgbClr val="4A3226"/>
+                </a:solidFill>
+                <a:latin typeface="DejaVu Sans"/>
+              </a:rPr>
+              <a:t>0.966</a:t>
+            </a:r>
+          </a:p>
+          <a:p>
+            <a:pPr algn="l">
+              <a:spcBef>
+                <a:spcPts val="400"/>
+              </a:spcBef>
+            </a:pPr>
+            <a:r>
+              <a:rPr sz="1500" b="1">
+                <a:solidFill>
+                  <a:srgbClr val="4A3226"/>
+                </a:solidFill>
+                <a:latin typeface="DejaVu Sans"/>
+              </a:rPr>
+              <a:t>mask IoU vs SAM 3</a:t>
+            </a:r>
+          </a:p>
+          <a:p>
+            <a:pPr algn="l">
+              <a:spcBef>
+                <a:spcPts val="600"/>
+              </a:spcBef>
+            </a:pPr>
+            <a:r>
+              <a:rPr sz="1100" b="0">
+                <a:solidFill>
+                  <a:srgbClr val="4A3226"/>
+                </a:solidFill>
+                <a:latin typeface="DejaVu Sans"/>
+              </a:rPr>
+              <a:t>225 held-out frames</a:t>
+            </a:r>
+          </a:p>
+        </p:txBody>
+      </p:sp>
+      <p:sp>
+        <p:nvSpPr>
+          <p:cNvPr id="4" name="Rounded Rectangle 3"/>
+          <p:cNvSpPr/>
+          <p:nvPr/>
+        </p:nvSpPr>
+        <p:spPr>
+          <a:xfrm>
+            <a:off x="3298698" y="1325880"/>
+            <a:ext cx="2658618" cy="2286000"/>
+          </a:xfrm>
+          <a:prstGeom prst="roundRect">
+            <a:avLst>
+              <a:gd name="adj" fmla="val 12000"/>
+            </a:avLst>
+          </a:prstGeom>
+          <a:solidFill>
+            <a:srgbClr val="F28B9B"/>
+          </a:solidFill>
+          <a:ln w="15875">
+            <a:solidFill>
+              <a:srgbClr val="E8A87C"/>
+            </a:solidFill>
+          </a:ln>
+          <a:effectLst/>
+        </p:spPr>
+        <p:style>
+          <a:lnRef idx="1">
+            <a:schemeClr val="accent1"/>
+          </a:lnRef>
+          <a:fillRef idx="3">
+            <a:schemeClr val="accent1"/>
+          </a:fillRef>
+          <a:effectRef idx="2">
+            <a:schemeClr val="accent1"/>
+          </a:effectRef>
+          <a:fontRef idx="minor">
+            <a:schemeClr val="lt1"/>
+          </a:fontRef>
+        </p:style>
+        <p:txBody>
+          <a:bodyPr rtlCol="0" anchor="ctr" wrap="square" lIns="164592" rIns="164592" tIns="219456" bIns="146304"/>
+          <a:lstStyle/>
+          <a:p>
+            <a:pPr algn="l"/>
+            <a:r>
+              <a:rPr sz="4000" b="1">
+                <a:solidFill>
+                  <a:srgbClr val="4A3226"/>
+                </a:solidFill>
+                <a:latin typeface="DejaVu Sans"/>
+              </a:rPr>
+              <a:t>0.944</a:t>
+            </a:r>
+          </a:p>
+          <a:p>
+            <a:pPr algn="l">
+              <a:spcBef>
+                <a:spcPts val="400"/>
+              </a:spcBef>
+            </a:pPr>
+            <a:r>
+              <a:rPr sz="1500" b="1">
+                <a:solidFill>
+                  <a:srgbClr val="4A3226"/>
+                </a:solidFill>
+                <a:latin typeface="DejaVu Sans"/>
+              </a:rPr>
+              <a:t>median IoU vs human</a:t>
+            </a:r>
+          </a:p>
+          <a:p>
+            <a:pPr algn="l">
+              <a:spcBef>
+                <a:spcPts val="600"/>
+              </a:spcBef>
+            </a:pPr>
+            <a:r>
+              <a:rPr sz="1100" b="0">
+                <a:solidFill>
+                  <a:srgbClr val="4A3226"/>
+                </a:solidFill>
+                <a:latin typeface="DejaVu Sans"/>
+              </a:rPr>
+              <a:t>62 valid masks</a:t>
+            </a:r>
+          </a:p>
+        </p:txBody>
+      </p:sp>
+      <p:sp>
+        <p:nvSpPr>
+          <p:cNvPr id="5" name="Rounded Rectangle 4"/>
+          <p:cNvSpPr/>
+          <p:nvPr/>
+        </p:nvSpPr>
+        <p:spPr>
+          <a:xfrm>
+            <a:off x="6231636" y="1325880"/>
+            <a:ext cx="2658618" cy="2286000"/>
+          </a:xfrm>
+          <a:prstGeom prst="roundRect">
+            <a:avLst>
+              <a:gd name="adj" fmla="val 12000"/>
+            </a:avLst>
+          </a:prstGeom>
+          <a:solidFill>
+            <a:srgbClr val="E8A87C"/>
+          </a:solidFill>
+          <a:ln w="15875">
+            <a:solidFill>
+              <a:srgbClr val="E8A87C"/>
+            </a:solidFill>
+          </a:ln>
+          <a:effectLst/>
+        </p:spPr>
+        <p:style>
+          <a:lnRef idx="1">
+            <a:schemeClr val="accent1"/>
+          </a:lnRef>
+          <a:fillRef idx="3">
+            <a:schemeClr val="accent1"/>
+          </a:fillRef>
+          <a:effectRef idx="2">
+            <a:schemeClr val="accent1"/>
+          </a:effectRef>
+          <a:fontRef idx="minor">
+            <a:schemeClr val="lt1"/>
+          </a:fontRef>
+        </p:style>
+        <p:txBody>
+          <a:bodyPr rtlCol="0" anchor="ctr" wrap="square" lIns="164592" rIns="164592" tIns="219456" bIns="146304"/>
+          <a:lstStyle/>
+          <a:p>
+            <a:pPr algn="l"/>
+            <a:r>
+              <a:rPr sz="4000" b="1">
+                <a:solidFill>
+                  <a:srgbClr val="4A3226"/>
+                </a:solidFill>
+                <a:latin typeface="DejaVu Sans"/>
+              </a:rPr>
+              <a:t>99.5%</a:t>
+            </a:r>
+          </a:p>
+          <a:p>
+            <a:pPr algn="l">
+              <a:spcBef>
+                <a:spcPts val="400"/>
+              </a:spcBef>
+            </a:pPr>
+            <a:r>
+              <a:rPr sz="1500" b="1">
+                <a:solidFill>
+                  <a:srgbClr val="4A3226"/>
+                </a:solidFill>
+                <a:latin typeface="DejaVu Sans"/>
+              </a:rPr>
+              <a:t>fold-state agreement</a:t>
+            </a:r>
+          </a:p>
+          <a:p>
+            <a:pPr algn="l">
+              <a:spcBef>
+                <a:spcPts val="600"/>
+              </a:spcBef>
+            </a:pPr>
+            <a:r>
+              <a:rPr sz="1100" b="0">
+                <a:solidFill>
+                  <a:srgbClr val="4A3226"/>
+                </a:solidFill>
+                <a:latin typeface="DejaVu Sans"/>
+              </a:rPr>
+              <a:t>991 passed-check moments</a:t>
+            </a:r>
+          </a:p>
+        </p:txBody>
+      </p:sp>
+      <p:sp>
+        <p:nvSpPr>
+          <p:cNvPr id="6" name="Rounded Rectangle 5"/>
+          <p:cNvSpPr/>
+          <p:nvPr/>
+        </p:nvSpPr>
+        <p:spPr>
+          <a:xfrm>
+            <a:off x="9164574" y="1325880"/>
+            <a:ext cx="2658618" cy="2286000"/>
+          </a:xfrm>
+          <a:prstGeom prst="roundRect">
+            <a:avLst>
+              <a:gd name="adj" fmla="val 12000"/>
+            </a:avLst>
+          </a:prstGeom>
+          <a:solidFill>
+            <a:srgbClr val="F28B9B"/>
+          </a:solidFill>
+          <a:ln w="15875">
+            <a:solidFill>
+              <a:srgbClr val="E8A87C"/>
+            </a:solidFill>
+          </a:ln>
+          <a:effectLst/>
+        </p:spPr>
+        <p:style>
+          <a:lnRef idx="1">
+            <a:schemeClr val="accent1"/>
+          </a:lnRef>
+          <a:fillRef idx="3">
+            <a:schemeClr val="accent1"/>
+          </a:fillRef>
+          <a:effectRef idx="2">
+            <a:schemeClr val="accent1"/>
+          </a:effectRef>
+          <a:fontRef idx="minor">
+            <a:schemeClr val="lt1"/>
+          </a:fontRef>
+        </p:style>
+        <p:txBody>
+          <a:bodyPr rtlCol="0" anchor="ctr" wrap="square" lIns="164592" rIns="164592" tIns="219456" bIns="146304"/>
+          <a:lstStyle/>
+          <a:p>
+            <a:pPr algn="l"/>
+            <a:r>
+              <a:rPr sz="3100" b="1">
+                <a:solidFill>
+                  <a:srgbClr val="4A3226"/>
+                </a:solidFill>
+                <a:latin typeface="DejaVu Sans"/>
+              </a:rPr>
+              <a:t>0.67-0.92</a:t>
+            </a:r>
+          </a:p>
+          <a:p>
+            <a:pPr algn="l">
+              <a:spcBef>
+                <a:spcPts val="400"/>
+              </a:spcBef>
+            </a:pPr>
+            <a:r>
+              <a:rPr sz="1500" b="1">
+                <a:solidFill>
+                  <a:srgbClr val="4A3226"/>
+                </a:solidFill>
+                <a:latin typeface="DejaVu Sans"/>
+              </a:rPr>
+              <a:t>check-head balanced accuracy</a:t>
+            </a:r>
+          </a:p>
+          <a:p>
+            <a:pPr algn="l">
+              <a:spcBef>
+                <a:spcPts val="600"/>
+              </a:spcBef>
+            </a:pPr>
+            <a:r>
+              <a:rPr sz="1100" b="0">
+                <a:solidFill>
+                  <a:srgbClr val="4A3226"/>
+                </a:solidFill>
+                <a:latin typeface="DejaVu Sans"/>
+              </a:rPr>
+              <a:t>31-61 frame holdouts</a:t>
+            </a:r>
+          </a:p>
+        </p:txBody>
+      </p:sp>
+      <p:sp>
+        <p:nvSpPr>
+          <p:cNvPr id="7" name="TextBox 6"/>
           <p:cNvSpPr txBox="1"/>
           <p:nvPr/>
         </p:nvSpPr>
         <p:spPr>
           <a:xfrm>
-            <a:off x="640080" y="1463040"/>
-            <a:ext cx="10972800" cy="4572000"/>
+            <a:off x="640080" y="3977640"/>
+            <a:ext cx="10972800" cy="2103120"/>
           </a:xfrm>
           <a:prstGeom prst="rect">
             <a:avLst/>
@@ -4417,18 +4792,17 @@
                 <a:spcPct val="100000"/>
               </a:lnSpc>
               <a:spcAft>
-                <a:spcPts val="2400"/>
+                <a:spcPts val="900"/>
               </a:spcAft>
             </a:pPr>
             <a:r>
-              <a:rPr sz="1800" b="1">
-                <a:solidFill>
-                  <a:srgbClr val="F28B9B"/>
+              <a:rPr sz="1300" b="0">
+                <a:solidFill>
+                  <a:srgbClr val="4A3226"/>
                 </a:solidFill>
                 <a:latin typeface="DejaVu Sans"/>
-                <a:hlinkClick r:id="rId3"/>
               </a:rPr>
-              <a:t>Explore the project: github.com/leonardoAB1/maus-crepe-insights</a:t>
+              <a:t>- Teacher IoU compares with SAM 3 masks, not ground truth.</a:t>
             </a:r>
           </a:p>
           <a:p>
@@ -4437,17 +4811,17 @@
                 <a:spcPct val="100000"/>
               </a:lnSpc>
               <a:spcAft>
-                <a:spcPts val="2200"/>
+                <a:spcPts val="900"/>
               </a:spcAft>
             </a:pPr>
             <a:r>
-              <a:rPr sz="1800" b="1">
-                <a:solidFill>
-                  <a:srgbClr val="E8A87C"/>
+              <a:rPr sz="1300" b="0">
+                <a:solidFill>
+                  <a:srgbClr val="4A3226"/>
                 </a:solidFill>
                 <a:latin typeface="DejaVu Sans"/>
               </a:rPr>
-              <a:t>Compare batches using the run table, camera-derived metrics and recipe settings.</a:t>
+              <a:t>- Human-mask review spans five runs on one robot; four were in student training.</a:t>
             </a:r>
           </a:p>
           <a:p>
@@ -4456,24 +4830,24 @@
                 <a:spcPct val="100000"/>
               </a:lnSpc>
               <a:spcAft>
-                <a:spcPts val="1200"/>
+                <a:spcPts val="900"/>
               </a:spcAft>
             </a:pPr>
             <a:r>
-              <a:rPr sz="1700" b="0">
+              <a:rPr sz="1300" b="0">
                 <a:solidFill>
                   <a:srgbClr val="4A3226"/>
                 </a:solidFill>
                 <a:latin typeface="DejaVu Sans"/>
               </a:rPr>
-              <a:t>Bring more run records and check images into the analysis, then use the evidence to shape the next experiment.</a:t>
-            </a:r>
-          </a:p>
-        </p:txBody>
-      </p:sp>
-      <p:sp>
-        <p:nvSpPr>
-          <p:cNvPr id="4" name="TextBox 3"/>
+              <a:t>- Fold thresholds use the same passed-check frames; check-head labels are robot verdicts.</a:t>
+            </a:r>
+          </a:p>
+        </p:txBody>
+      </p:sp>
+      <p:sp>
+        <p:nvSpPr>
+          <p:cNvPr id="8" name="TextBox 7"/>
           <p:cNvSpPr txBox="1"/>
           <p:nvPr/>
         </p:nvSpPr>
@@ -4499,15 +4873,16 @@
                   <a:srgbClr val="9C7A63"/>
                 </a:solidFill>
                 <a:latin typeface="DejaVu Sans"/>
+                <a:hlinkClick r:id="rId3"/>
               </a:rPr>
-              <a:t>Public code; run data stays private</a:t>
-            </a:r>
-          </a:p>
-        </p:txBody>
-      </p:sp>
-      <p:sp>
-        <p:nvSpPr>
-          <p:cNvPr id="5" name="TextBox 4"/>
+              <a:t>Explore the public repo</a:t>
+            </a:r>
+          </a:p>
+        </p:txBody>
+      </p:sp>
+      <p:sp>
+        <p:nvSpPr>
+          <p:cNvPr id="9" name="TextBox 8"/>
           <p:cNvSpPr txBox="1"/>
           <p:nvPr/>
         </p:nvSpPr>

</xml_diff>